<commit_message>
Make all bet subtitles and What We Need bullets dynamic
Both scripts now fetch live status/priority from Jira API instead of
hardcoding values that go stale between runs. AICP script adds DRA
query, get_strat_status(), and dynamic top-blocker names. AI Hub
script adds get_issue_status() for all 4 bet issues. Regenerated
both decks with current data.

Co-Authored-By: Claude Opus 4.6 <noreply@anthropic.com>
</commit_message>
<xml_diff>
--- a/docs/strategy/2026-06-11_ai_hub_strategy_review.pptx
+++ b/docs/strategy/2026-06-11_ai_hub_strategy_review.pptx
@@ -3403,7 +3403,7 @@
                 </a:solidFill>
                 <a:latin typeface="Calibri"/>
               </a:rPr>
-              <a:t>RHOAIENG-63382 / RHOAIENG-63350  ·  Tech Preview  ·  In Progress</a:t>
+              <a:t>RHOAIENG-63382 (New) / RHOAIENG-63350 (New)  ·  Tech Preview</a:t>
             </a:r>
           </a:p>
         </p:txBody>
@@ -3760,7 +3760,7 @@
                 </a:solidFill>
                 <a:latin typeface="Calibri"/>
               </a:rPr>
-              <a:t>RHOAIENG-60367  ·  Major  ·  New — stories scoped, not yet started</a:t>
+              <a:t>RHOAIENG-60367  ·  Undefined  ·  New</a:t>
             </a:r>
           </a:p>
         </p:txBody>
@@ -7293,7 +7293,7 @@
                 </a:solidFill>
                 <a:latin typeface="Calibri"/>
               </a:rPr>
-              <a:t>RHOAIENG-50747  ·  Tiger Team  ·  In Progress</a:t>
+              <a:t>RHOAIENG-50747  ·  Major  ·  Tiger Team  ·  New</a:t>
             </a:r>
           </a:p>
         </p:txBody>
@@ -7405,7 +7405,7 @@
                 <a:latin typeface="Calibri"/>
               </a:rPr>
               <a:t>Kubeflow Model Registry is a narrowly scoped model metadata store. Customers need a unified registry that covers models, experiments, datasets, and artifacts — with lineage, governance, and multi-tenancy built in.
-MLflow / Unity Catalog OSS has emerged as the leading open-source candidate for this role. Multiple enterprise customers are already running MLflow and expect RHOAI to integrate with it rather than requiring migration to a proprietary registry.
+MLflow has emerged as the leading open-source candidate for this role. Multiple enterprise customers are already running MLflow and expect RHOAI to integrate with it rather than requiring migration to a proprietary registry.
 Research the feasibility of moving Kubeflow Model Registry to MLFlow Model Registry
 </a:t>
             </a:r>

</xml_diff>